<commit_message>
vault backup: 2026-06-06 09:47:44
</commit_message>
<xml_diff>
--- a/ресурсы/Медиакит.pptx
+++ b/ресурсы/Медиакит.pptx
@@ -1922,9 +1922,11 @@
                 <a:ea typeface="Calibri" pitchFamily="34" charset="-122"/>
                 <a:cs typeface="Calibri" pitchFamily="34" charset="-120"/>
               </a:rPr>
-              <a:t>— создаю контент о фитнесе и осознанном образе жизни.
-</a:t>
-            </a:r>
+              <a:t>— создаю контент о фитнесе и осознанном образе жизни.</a:t>
+            </a:r>
+            <a:endParaRPr lang="en-US" sz="1600" dirty="0"/>
+          </a:p>
+          <a:p>
             <a:pPr algn="l" indent="0" marL="0">
               <a:lnSpc>
                 <a:spcPct val="115000"/>
@@ -1940,9 +1942,51 @@
                 <a:ea typeface="Calibri" pitchFamily="34" charset="-122"/>
                 <a:cs typeface="Calibri" pitchFamily="34" charset="-120"/>
               </a:rPr>
-              <a:t>Помогаю девушкам полюбить спорт без насилия над собой: простые тренировки дома, питание без жёстких диет и мотивация на каждый день.
-</a:t>
-            </a:r>
+              <a:t> </a:t>
+            </a:r>
+            <a:endParaRPr lang="en-US" sz="1600" dirty="0"/>
+          </a:p>
+          <a:p>
+            <a:pPr algn="l" indent="0" marL="0">
+              <a:lnSpc>
+                <a:spcPct val="115000"/>
+              </a:lnSpc>
+              <a:buNone/>
+            </a:pPr>
+            <a:r>
+              <a:rPr lang="en-US" sz="1600" dirty="0">
+                <a:solidFill>
+                  <a:srgbClr val="2B2024"/>
+                </a:solidFill>
+                <a:latin typeface="Calibri" pitchFamily="34" charset="0"/>
+                <a:ea typeface="Calibri" pitchFamily="34" charset="-122"/>
+                <a:cs typeface="Calibri" pitchFamily="34" charset="-120"/>
+              </a:rPr>
+              <a:t>Помогаю девушкам полюбить спорт без насилия над собой: простые тренировки дома, питание без жёстких диет и мотивация на каждый день.</a:t>
+            </a:r>
+            <a:endParaRPr lang="en-US" sz="1600" dirty="0"/>
+          </a:p>
+          <a:p>
+            <a:pPr algn="l" indent="0" marL="0">
+              <a:lnSpc>
+                <a:spcPct val="115000"/>
+              </a:lnSpc>
+              <a:buNone/>
+            </a:pPr>
+            <a:r>
+              <a:rPr lang="en-US" sz="1600" dirty="0">
+                <a:solidFill>
+                  <a:srgbClr val="2B2024"/>
+                </a:solidFill>
+                <a:latin typeface="Calibri" pitchFamily="34" charset="0"/>
+                <a:ea typeface="Calibri" pitchFamily="34" charset="-122"/>
+                <a:cs typeface="Calibri" pitchFamily="34" charset="-120"/>
+              </a:rPr>
+              <a:t> </a:t>
+            </a:r>
+            <a:endParaRPr lang="en-US" sz="1600" dirty="0"/>
+          </a:p>
+          <a:p>
             <a:pPr algn="l" indent="0" marL="0">
               <a:lnSpc>
                 <a:spcPct val="115000"/>
@@ -5390,9 +5434,11 @@
                 <a:ea typeface="Calibri" pitchFamily="34" charset="-122"/>
                 <a:cs typeface="Calibri" pitchFamily="34" charset="-120"/>
               </a:rPr>
-              <a:t>📧   [ваш-email]@mail.ru
-</a:t>
-            </a:r>
+              <a:t>📧   [ваш-email]@mail.ru</a:t>
+            </a:r>
+            <a:endParaRPr lang="en-US" sz="2000" dirty="0"/>
+          </a:p>
+          <a:p>
             <a:pPr indent="0" marL="0">
               <a:lnSpc>
                 <a:spcPct val="100000"/>
@@ -5408,9 +5454,51 @@
                 <a:ea typeface="Calibri" pitchFamily="34" charset="-122"/>
                 <a:cs typeface="Calibri" pitchFamily="34" charset="-120"/>
               </a:rPr>
-              <a:t>✈️   Telegram:  @[ваш_аккаунт]
-</a:t>
-            </a:r>
+              <a:t> </a:t>
+            </a:r>
+            <a:endParaRPr lang="en-US" sz="2000" dirty="0"/>
+          </a:p>
+          <a:p>
+            <a:pPr indent="0" marL="0">
+              <a:lnSpc>
+                <a:spcPct val="100000"/>
+              </a:lnSpc>
+              <a:buNone/>
+            </a:pPr>
+            <a:r>
+              <a:rPr lang="en-US" sz="2000" dirty="0">
+                <a:solidFill>
+                  <a:srgbClr val="ECE2D0"/>
+                </a:solidFill>
+                <a:latin typeface="Calibri" pitchFamily="34" charset="0"/>
+                <a:ea typeface="Calibri" pitchFamily="34" charset="-122"/>
+                <a:cs typeface="Calibri" pitchFamily="34" charset="-120"/>
+              </a:rPr>
+              <a:t>✈️   Telegram:  @[ваш_аккаунт]</a:t>
+            </a:r>
+            <a:endParaRPr lang="en-US" sz="2000" dirty="0"/>
+          </a:p>
+          <a:p>
+            <a:pPr indent="0" marL="0">
+              <a:lnSpc>
+                <a:spcPct val="100000"/>
+              </a:lnSpc>
+              <a:buNone/>
+            </a:pPr>
+            <a:r>
+              <a:rPr lang="en-US" sz="2000" dirty="0">
+                <a:solidFill>
+                  <a:srgbClr val="ECE2D0"/>
+                </a:solidFill>
+                <a:latin typeface="Calibri" pitchFamily="34" charset="0"/>
+                <a:ea typeface="Calibri" pitchFamily="34" charset="-122"/>
+                <a:cs typeface="Calibri" pitchFamily="34" charset="-120"/>
+              </a:rPr>
+              <a:t> </a:t>
+            </a:r>
+            <a:endParaRPr lang="en-US" sz="2000" dirty="0"/>
+          </a:p>
+          <a:p>
             <a:pPr indent="0" marL="0">
               <a:lnSpc>
                 <a:spcPct val="100000"/>

</xml_diff>